<commit_message>
Deck now quotes the dedicated evaluation, not the training-time log
scripts/evaluate.py finished on the pinned checkpoint: all 9,381 held-out
windows, split verified against the run's own record.  The in-training
validation the deck was reading is a 150-batch sample of the same set, so it
was the weaker source.  Every figure moves slightly in the model's favour:

                      sampled   full
  model                0.8046   0.8064
  persistence          0.4503   0.4649
  constant velocity    0.5038   0.5165
  vehicle count error   2.37%    2.22%

Both the slide and the horizon chart now read evaluation.json, and the claim
lines and speaker notes interpolate the measured values rather than carrying
typed copies of them.

Co-Authored-By: Claude Opus 5 (1M context) <noreply@anthropic.com>
Claude-Session: https://claude.ai/code/session_013fDMU3cBbvU3456DsDfVNU
</commit_message>
<xml_diff>
--- a/docs/slides/GTraffic2Crash.pptx
+++ b/docs/slides/GTraffic2Crash.pptx
@@ -1127,7 +1127,7 @@
           </a:p>
           <a:p>
             <a:r>
-              <a:t>runs 1.005 at +0.5 s to 1.042 at +5 s, so the overlap is real rather than</a:t>
+              <a:t>runs 1.003 at +0.5 s to 1.041 at +5 s, so the overlap is real rather than</a:t>
             </a:r>
           </a:p>
           <a:p>
@@ -1143,12 +1143,12 @@
           <a:p/>
           <a:p>
             <a:r>
-              <a:t>Per-horizon soft IoU: 0.920, 0.895, 0.870, 0.844, 0.817, 0.790, 0.765, 0.740,</a:t>
-            </a:r>
-          </a:p>
-          <a:p>
-            <a:r>
-              <a:t>0.715, 0.690.</a:t>
+              <a:t>Per-horizon soft IoU: 0.921, 0.896, 0.871, 0.845, 0.818, 0.792, 0.767, 0.742, 0.718, 0.692.</a:t>
+            </a:r>
+          </a:p>
+          <a:p>
+            <a:r>
+              <a:t>Per-horizon BIAS: 1.003, 1.005, 1.007, 1.009, 1.012, 1.016, 1.021, 1.026, 1.033, 1.041.</a:t>
             </a:r>
           </a:p>
         </p:txBody>
@@ -6419,7 +6419,7 @@
                           </a:solidFill>
                           <a:latin typeface="Arial"/>
                         </a:rPr>
-                        <a:t>0.805</a:t>
+                        <a:t>0.806</a:t>
                       </a:r>
                     </a:p>
                   </a:txBody>
@@ -6447,7 +6447,7 @@
                           </a:solidFill>
                           <a:latin typeface="Arial"/>
                         </a:rPr>
-                        <a:t>0.690</a:t>
+                        <a:t>0.692</a:t>
                       </a:r>
                     </a:p>
                   </a:txBody>
@@ -6505,7 +6505,7 @@
                           </a:solidFill>
                           <a:latin typeface="Arial"/>
                         </a:rPr>
-                        <a:t>0.450</a:t>
+                        <a:t>0.465</a:t>
                       </a:r>
                     </a:p>
                   </a:txBody>
@@ -6533,7 +6533,7 @@
                           </a:solidFill>
                           <a:latin typeface="Arial"/>
                         </a:rPr>
-                        <a:t>0.394</a:t>
+                        <a:t>0.408</a:t>
                       </a:r>
                     </a:p>
                   </a:txBody>
@@ -6591,7 +6591,7 @@
                           </a:solidFill>
                           <a:latin typeface="Arial"/>
                         </a:rPr>
-                        <a:t>0.504</a:t>
+                        <a:t>0.517</a:t>
                       </a:r>
                     </a:p>
                   </a:txBody>
@@ -6619,7 +6619,7 @@
                           </a:solidFill>
                           <a:latin typeface="Arial"/>
                         </a:rPr>
-                        <a:t>0.391</a:t>
+                        <a:t>0.404</a:t>
                       </a:r>
                     </a:p>
                   </a:txBody>
@@ -6677,7 +6677,7 @@
                           </a:solidFill>
                           <a:latin typeface="Arial"/>
                         </a:rPr>
-                        <a:t>0.390</a:t>
+                        <a:t>0.400</a:t>
                       </a:r>
                     </a:p>
                   </a:txBody>
@@ -6705,7 +6705,7 @@
                           </a:solidFill>
                           <a:latin typeface="Arial"/>
                         </a:rPr>
-                        <a:t>0.265</a:t>
+                        <a:t>0.276</a:t>
                       </a:r>
                     </a:p>
                   </a:txBody>
@@ -6795,7 +6795,7 @@
                 </a:solidFill>
                 <a:latin typeface="Arial"/>
               </a:rPr>
-              <a:t>Predicted vehicle count stays within 2.4 % of the truth across the whole horizon.</a:t>
+              <a:t>Predicted vehicle count stays within 2.2 % of the truth across the whole horizon.</a:t>
             </a:r>
           </a:p>
           <a:p>
@@ -6823,7 +6823,7 @@
                 </a:solidFill>
                 <a:latin typeface="Arial"/>
               </a:rPr>
-              <a:t>Collision episodes score 0.796 against 0.814 on nominal traffic — two points, not the result.</a:t>
+              <a:t>Collision episodes score 0.798 against 0.814 on nominal traffic — two points, not the result.</a:t>
             </a:r>
           </a:p>
           <a:p>

</xml_diff>